<commit_message>
Add MCC 32-point (option B) quote and internal margin files; align decks and comparison sheet to option B
Co-Authored-By: Claude Opus 5.5 <noreply@anthropic.com>
Claude-Session: https://claude.ai/code/session_01GjFrCobQqqs1TtLcuKd8BA
</commit_message>
<xml_diff>
--- a/32점안_검토/PLC_사양서_261006_32점안.pptx
+++ b/32점안_검토/PLC_사양서_261006_32점안.pptx
@@ -9147,7 +9147,18 @@
                             <a:srgbClr val="FF0000"/>
                           </a:solidFill>
                         </a:rPr>
-                        <a:t>TM3DI32K × 3</a:t>
+                        <a:t>TM3DI32K × 2</a:t>
+                      </a:r>
+                    </a:p>
+                    <a:p>
+                      <a:pPr algn="ctr" latinLnBrk="1"/>
+                      <a:r>
+                        <a:rPr lang="en-US" altLang="ko-KR" sz="1000" dirty="0">
+                          <a:solidFill>
+                            <a:srgbClr val="FF0000"/>
+                          </a:solidFill>
+                        </a:rPr>
+                        <a:t>TM3DI16</a:t>
                       </a:r>
                     </a:p>
                     <a:p>
@@ -9177,7 +9188,7 @@
                       <a:r>
                         <a:rPr lang="en-US" altLang="ko-KR" sz="1000" dirty="0">
                           <a:solidFill>
-                            <a:srgbClr val="1F1F1F"/>
+                            <a:srgbClr val="FF0000"/>
                           </a:solidFill>
                         </a:rPr>
                         <a:t>TM3AQ4</a:t>
@@ -9508,7 +9519,7 @@
                             <a:srgbClr val="FF0000"/>
                           </a:solidFill>
                         </a:rPr>
-                        <a:t>33.5×81.3×90 (×4)</a:t>
+                        <a:t>33.5×81.3×90 (×3)</a:t>
                       </a:r>
                     </a:p>
                     <a:p>
@@ -9535,7 +9546,7 @@
                             <a:srgbClr val="FF0000"/>
                           </a:solidFill>
                         </a:rPr>
-                        <a:t>27.4×84.6×90</a:t>
+                        <a:t>27.4×84.6×90 (×2)</a:t>
                       </a:r>
                     </a:p>
                     <a:p>
@@ -10241,7 +10252,7 @@
                             <a:srgbClr val="FF0000"/>
                           </a:solidFill>
                         </a:rPr>
-                        <a:t>120/56/0/4</a:t>
+                        <a:t>104/56/0/4</a:t>
                       </a:r>
                     </a:p>
                   </a:txBody>

</xml_diff>